<commit_message>
izvestaj i prezentacija v1
</commit_message>
<xml_diff>
--- a/Predikcija_Bitcoina_Prezentacija.pptx
+++ b/Predikcija_Bitcoina_Prezentacija.pptx
@@ -3583,7 +3583,23 @@
                   <a:srgbClr val="6B7A8D"/>
                 </a:solidFill>
               </a:rPr>
-              <a:t>Istraživanja pokazuju 6–12h pomak između Twitter sentimenta i cene [Karami, 2022]</a:t>
+              <a:t>Istraživanja </a:t>
+            </a:r>
+            <a:r>
+              <a:rPr lang="en-US" sz="1100" dirty="0" err="1">
+                <a:solidFill>
+                  <a:srgbClr val="6B7A8D"/>
+                </a:solidFill>
+              </a:rPr>
+              <a:t>pokazuju</a:t>
+            </a:r>
+            <a:r>
+              <a:rPr lang="en-US" sz="1100" dirty="0">
+                <a:solidFill>
+                  <a:srgbClr val="6B7A8D"/>
+                </a:solidFill>
+              </a:rPr>
+              <a:t> 6-12h pomak između Twitter sentimenta i cene [Karami, 2022]</a:t>
             </a:r>
             <a:endParaRPr lang="en-US" sz="1100" dirty="0"/>
           </a:p>
@@ -5888,7 +5904,7 @@
                   <a:srgbClr val="F0F4F8"/>
                 </a:solidFill>
               </a:rPr>
-              <a:t>Pearsonov ρ ∈ [-0.009, -0.017] za sve lag vrednosti (0h–48h), p &gt; 0.3 - statistički beznačajno.</a:t>
+              <a:t>Pearsonov ρ ∈ [-0.009, -0.017] za sve lag vrednosti (0h-48h), p &gt; 0.3 - statistički beznačajno.</a:t>
             </a:r>
             <a:endParaRPr lang="en-US" sz="1100" dirty="0"/>
           </a:p>
@@ -10278,7 +10294,7 @@
                   <a:srgbClr val="6B7A8D"/>
                 </a:solidFill>
               </a:rPr>
-              <a:t>&lt; dummy!</a:t>
+              <a:t>&lt; dummy</a:t>
             </a:r>
             <a:endParaRPr lang="en-US" sz="900" dirty="0"/>
           </a:p>

</xml_diff>

<commit_message>
izvestaj i prezentacija v2
</commit_message>
<xml_diff>
--- a/Predikcija_Bitcoina_Prezentacija.pptx
+++ b/Predikcija_Bitcoina_Prezentacija.pptx
@@ -3599,7 +3599,31 @@
                   <a:srgbClr val="6B7A8D"/>
                 </a:solidFill>
               </a:rPr>
-              <a:t> 6-12h pomak između Twitter sentimenta i cene [Karami, 2022]</a:t>
+              <a:t> 6-12h pomak između Twitter sentimenta i </a:t>
+            </a:r>
+            <a:r>
+              <a:rPr lang="en-US" sz="1100" dirty="0" err="1">
+                <a:solidFill>
+                  <a:srgbClr val="6B7A8D"/>
+                </a:solidFill>
+              </a:rPr>
+              <a:t>cene</a:t>
+            </a:r>
+            <a:r>
+              <a:rPr lang="en-US" sz="1100" dirty="0">
+                <a:solidFill>
+                  <a:srgbClr val="6B7A8D"/>
+                </a:solidFill>
+              </a:rPr>
+              <a:t> [H. G. </a:t>
+            </a:r>
+            <a:r>
+              <a:rPr lang="en-US" sz="1100">
+                <a:solidFill>
+                  <a:srgbClr val="6B7A8D"/>
+                </a:solidFill>
+              </a:rPr>
+              <a:t>B., 2023]</a:t>
             </a:r>
             <a:endParaRPr lang="en-US" sz="1100" dirty="0"/>
           </a:p>

</xml_diff>